<commit_message>
feat: apply logo 08D and Inteligência para decisão across brand guide
</commit_message>
<xml_diff>
--- a/Template_Slides_NeuralMind_AI.pptx
+++ b/Template_Slides_NeuralMind_AI.pptx
@@ -4686,7 +4686,7 @@
         <p:spPr>
           <a:xfrm>
             <a:off x="960120" y="4279392"/>
-            <a:ext cx="4800600" cy="680953"/>
+            <a:ext cx="4800600" cy="453045"/>
           </a:xfrm>
           <a:prstGeom prst="rect">
             <a:avLst/>
@@ -4770,7 +4770,7 @@
                 </a:solidFill>
                 <a:latin typeface="NeuralMind Sans Square"/>
               </a:rPr>
-              <a:t>IA responsável para setores críticos.</a:t>
+              <a:t>Inteligência para decisão.</a:t>
             </a:r>
           </a:p>
         </p:txBody>
@@ -5803,7 +5803,7 @@
         <p:spPr>
           <a:xfrm>
             <a:off x="11109960" y="6236208"/>
-            <a:ext cx="658368" cy="311923"/>
+            <a:ext cx="658368" cy="274663"/>
           </a:xfrm>
           <a:prstGeom prst="rect">
             <a:avLst/>
@@ -6033,7 +6033,7 @@
         <p:spPr>
           <a:xfrm>
             <a:off x="777240" y="5687568"/>
-            <a:ext cx="2834640" cy="402087"/>
+            <a:ext cx="2834640" cy="267512"/>
           </a:xfrm>
           <a:prstGeom prst="rect">
             <a:avLst/>
@@ -6883,7 +6883,7 @@
         <p:spPr>
           <a:xfrm>
             <a:off x="11109960" y="6236208"/>
-            <a:ext cx="658368" cy="311923"/>
+            <a:ext cx="658368" cy="274663"/>
           </a:xfrm>
           <a:prstGeom prst="rect">
             <a:avLst/>
@@ -7920,7 +7920,7 @@
         <p:spPr>
           <a:xfrm>
             <a:off x="11109960" y="6236208"/>
-            <a:ext cx="658368" cy="311923"/>
+            <a:ext cx="658368" cy="274663"/>
           </a:xfrm>
           <a:prstGeom prst="rect">
             <a:avLst/>
@@ -10123,7 +10123,7 @@
         <p:spPr>
           <a:xfrm>
             <a:off x="11109960" y="6236208"/>
-            <a:ext cx="658368" cy="311923"/>
+            <a:ext cx="658368" cy="274663"/>
           </a:xfrm>
           <a:prstGeom prst="rect">
             <a:avLst/>
@@ -10287,7 +10287,7 @@
         <p:spPr>
           <a:xfrm>
             <a:off x="11109960" y="6236208"/>
-            <a:ext cx="658368" cy="311923"/>
+            <a:ext cx="658368" cy="274663"/>
           </a:xfrm>
           <a:prstGeom prst="rect">
             <a:avLst/>
@@ -10814,7 +10814,7 @@
         <p:spPr>
           <a:xfrm>
             <a:off x="11109960" y="6236208"/>
-            <a:ext cx="658368" cy="311923"/>
+            <a:ext cx="658368" cy="274663"/>
           </a:xfrm>
           <a:prstGeom prst="rect">
             <a:avLst/>
@@ -11021,7 +11021,7 @@
         <p:spPr>
           <a:xfrm>
             <a:off x="11109960" y="6236208"/>
-            <a:ext cx="658368" cy="311923"/>
+            <a:ext cx="658368" cy="274663"/>
           </a:xfrm>
           <a:prstGeom prst="rect">
             <a:avLst/>
@@ -11875,7 +11875,7 @@
         <p:spPr>
           <a:xfrm>
             <a:off x="11109960" y="6236208"/>
-            <a:ext cx="658368" cy="311923"/>
+            <a:ext cx="658368" cy="274663"/>
           </a:xfrm>
           <a:prstGeom prst="rect">
             <a:avLst/>
@@ -12039,7 +12039,7 @@
         <p:spPr>
           <a:xfrm>
             <a:off x="868680" y="5138928"/>
-            <a:ext cx="2880360" cy="408572"/>
+            <a:ext cx="2880360" cy="271827"/>
           </a:xfrm>
           <a:prstGeom prst="rect">
             <a:avLst/>

</xml_diff>